<commit_message>
docs(decks): professional-voice sweep — 0 ban-tier across all three decks
Reworded ban-tier editorializing (deliberately/genuine/on-purpose/honest/
earns-its-place) out of speaker notes, captions, and deck-authored code
comments in all three decks; verbatim example-code lines left intact.
100: 26->0, quarkus: 27->0, python: 17->0. Rebuilt all three pptx
(99/66/68 slides, notes parity exact).
</commit_message>
<xml_diff>
--- a/presentation/api-patterns-grpc-python/api-patterns-grpc-python-r1.0.pptx
+++ b/presentation/api-patterns-grpc-python/api-patterns-grpc-python-r1.0.pptx
@@ -1449,7 +1449,7 @@
           <a:p>
             <a:r>
               <a:rPr lang="en-US" dirty="0"/>
-              <a:t>This downstream service is artificially slow by design — a 2-second asyncio.sleep stands in for a real backend hop. The point isn't the delay, it's what happens when the upstream caller's deadline expires before that delay finishes: grpc.aio cancels the asyncio Task running this coroutine, and because asyncio.sleep is a real awaitable rather than a blocking call, Python's cancellation machinery raises asyncio.CancelledError at that exact await point rather than letting the sleep run out. The try/except here is deliberately thin — it logs that the work was abandoned early, then re-raises, because a cancelled coroutine must propagate that cancellation rather than swallow it. Contrast this with time.sleep, which cannot be interrupted this way at all; that distinction becomes the whole subject of the concurrency section later in this deck.</a:t>
+              <a:t>This downstream service is artificially slow by design — a 2-second asyncio.sleep stands in for a real backend hop. The point isn't the delay, it's what happens when the upstream caller's deadline expires before that delay finishes: grpc.aio cancels the asyncio Task running this coroutine, and because asyncio.sleep is a real awaitable rather than a blocking call, Python's cancellation machinery raises asyncio.CancelledError at that exact await point rather than letting the sleep run out. The try/except here stays thin: it logs that the work was abandoned early, then re-raises, because a cancelled coroutine must propagate that cancellation rather than swallow it. Contrast this with time.sleep, which cannot be interrupted this way at all; that distinction becomes the whole subject of the concurrency section later in this deck.</a:t>
             </a:r>
             <a:endParaRPr lang="en-US" dirty="0"/>
           </a:p>
@@ -2065,7 +2065,7 @@
           <a:p>
             <a:r>
               <a:rPr lang="en-US" dirty="0"/>
-              <a:t>grpc.aio runs every servicer coroutine on ONE event-loop thread. A coroutine that awaits cooperates; a coroutine that blocks in place — time.sleep, a blocking file read — freezes every other call on that loop for as long as it runs. asyncio.to_thread is the fix: it hands the identical blocking work to a thread-pool worker and awaits the result, so the loop stays free. The same CPython GIL that makes this concurrency model sound today is scheduled to become optional in the free-threaded 3.14 build — a caveat worth stating out loud, not assuming away.</a:t>
+              <a:t>grpc.aio runs every servicer coroutine on ONE event-loop thread. A coroutine that awaits cooperates; a coroutine that blocks in place — time.sleep, a blocking file read — freezes every other call on that loop for as long as it runs. asyncio.to_thread is the fix: it hands the identical blocking work to a thread-pool worker and awaits the result, so the loop stays free. The same CPython GIL that makes this concurrency model sound today is scheduled to become optional in the free-threaded 3.14 build, a change this model's assumptions will need to account for.</a:t>
             </a:r>
             <a:endParaRPr lang="en-US" dirty="0"/>
           </a:p>
@@ -2241,7 +2241,7 @@
           <a:p>
             <a:r>
               <a:rPr lang="en-US" dirty="0"/>
-              <a:t>This second figure is the direct, measured contrast the code on the next slide produces. Call the exact same ~400 millisecond blocking lookup inline, on the event loop's own thread, and every OTHER call waiting on that loop — including other FindOptimalRoute calls — queues behind it, because nothing can run until that one coroutine either awaits something or returns. Call the identical function through asyncio.to_thread instead, and the loop is free the instant that line suspends, so eight concurrent calls genuinely overlap rather than merely appearing to. Both modes produce the correct ANSWER every time; the only difference this section demonstrates is throughput under concurrent load, which is exactly the kind of bug that is invisible in a single-request test and only shows up once a dozen clients call the same endpoint at once.</a:t>
+              <a:t>This second figure is the direct, measured contrast the code on the next slide produces. Call the exact same ~400 millisecond blocking lookup inline, on the event loop's own thread, and every OTHER call waiting on that loop — including other FindOptimalRoute calls — queues behind it, because nothing can run until that one coroutine either awaits something or returns. Call the identical function through asyncio.to_thread instead, and the loop is free the instant that line suspends, so eight concurrent calls overlap rather than running one at a time. Both modes produce the correct ANSWER every time; the only difference this section demonstrates is throughput under concurrent load, which is exactly the kind of bug that is invisible in a single-request test and only shows up once a dozen clients call the same endpoint at once.</a:t>
             </a:r>
             <a:endParaRPr lang="en-US" dirty="0"/>
           </a:p>
@@ -2681,7 +2681,7 @@
           <a:p>
             <a:r>
               <a:rPr lang="en-US" dirty="0"/>
-              <a:t>GetOperation is a plain unary poll — look up the record, return its current snapshot, NOT_FOUND if the id doesn't exist. WatchOperation turns the identical state into a server stream: it yields one snapshot, checks whether that snapshot was terminal, and either returns — ending the stream, which is the same half-close mechanic Chapter 8's WatchShipment uses — or awaits a short poll interval and loops. CancelOperation marks the record done early and returns whether THIS call was the one that moved it to terminal, which matters because a cancel arriving after the job already finished, or a duplicate cancel, should be distinguishable from the first one that actually took effect. The OperationRegistry backing all of this needs no lock: asyncio runs exactly one coroutine at a time, there's never a context switch mid-statement, so every await is the only point where another coroutine can interleave, and none of these state transitions span an await — a real structural difference from the Quarkus side, where the background job and the RPC handlers can genuinely run on different OS threads and do need a lock.</a:t>
+              <a:t>GetOperation is a plain unary poll — look up the record, return its current snapshot, NOT_FOUND if the id doesn't exist. WatchOperation turns the identical state into a server stream: it yields one snapshot, checks whether that snapshot was terminal, and either returns — ending the stream, which is the same half-close mechanic Chapter 8's WatchShipment uses — or awaits a short poll interval and loops. CancelOperation marks the record done early and returns whether THIS call was the one that moved it to terminal, which matters because a cancel arriving after the job already finished, or a duplicate cancel, should be distinguishable from the first one that actually took effect. The OperationRegistry backing all of this needs no lock: asyncio runs exactly one coroutine at a time, there's never a context switch mid-statement, so every await is the only point where another coroutine can interleave, and none of these state transitions span an await — a real structural difference from the Quarkus side, where the background job and the RPC handlers can run on different OS threads and do need a lock.</a:t>
             </a:r>
             <a:endParaRPr lang="en-US" dirty="0"/>
           </a:p>
@@ -2769,7 +2769,7 @@
           <a:p>
             <a:r>
               <a:rPr lang="en-US" dirty="0"/>
-              <a:t>Nothing extra is needed to make a Python streaming handler demand-driven — the async-generator protocol itself only resumes past a yield when the consumer is ready for the next item. From there, performance is almost entirely about the channel: build one and reuse it, size messages and compression deliberately, and keep keepalive pings tuned to survive real idle gaps without needless chatter.</a:t>
+              <a:t>Nothing extra is needed to make a Python streaming handler demand-driven — the async-generator protocol itself only resumes past a yield when the consumer is ready for the next item. From there, performance is almost entirely about the channel: build one and reuse it, size messages and compression for the workload, and keep keepalive pings tuned to survive real idle gaps without needless chatter.</a:t>
             </a:r>
             <a:endParaRPr lang="en-US" dirty="0"/>
           </a:p>
@@ -3385,7 +3385,7 @@
           <a:p>
             <a:r>
               <a:rPr lang="en-US" dirty="0"/>
-              <a:t>gRPC metadata is the one mechanism every cross-cutting concern in this deck rides on — logging, tracing, and now authentication all read and write the same key-value map, just under different keys. The diagram traces a JWT from the client's authorization header through the wire as metadata, into the interceptor that reads it before the real servicer method ever runs, through PyJWT's signature-and-expiry check, and finally into the per-method scope decision the next slide's code implements. Every authentication failure in this chapter — missing header, malformed Bearer prefix, bad signature, expired token — collapses into the same UNAUTHENTICATED outcome, deliberately, so a client can't distinguish 'your token expired' from 'you forged a signature' by status code alone.</a:t>
+              <a:t>gRPC metadata is the one mechanism every cross-cutting concern in this deck rides on — logging, tracing, and now authentication all read and write the same key-value map, just under different keys. The diagram traces a JWT from the client's authorization header through the wire as metadata, into the interceptor that reads it before the real servicer method ever runs, through PyJWT's signature-and-expiry check, and finally into the per-method scope decision the next slide's code implements. Every authentication failure in this chapter — missing header, malformed Bearer prefix, bad signature, expired token — collapses into the same UNAUTHENTICATED outcome, so a client can't distinguish 'your token expired' from 'you forged a signature' by status code alone.</a:t>
             </a:r>
             <a:endParaRPr lang="en-US" dirty="0"/>
           </a:p>
@@ -3737,7 +3737,7 @@
           <a:p>
             <a:r>
               <a:rPr lang="en-US" dirty="0"/>
-              <a:t>This figure lays out the three observability surfaces this chapter wires up in one process: Prometheus metrics scraped from GET /metrics on a co-located FastAPI app, a grpc.health.v1.Health service any orchestrator can poll, and OTLP traces exported by the zero-code opentelemetry-instrument wrapper. None of these are automatic the way they are on the Quarkus side — grpcio ships no Prometheus binder and no automatic health registration, so both are hand-wired here, in code shown next, following the exact same interceptor pattern Chapter 12 and Chapter 20 already established. The metric and label names — grpc_server_handled_total, grpc_server_handling_seconds, labeled by grpc_service, grpc_method, grpc_code — deliberately match the names the community's grpc-ecosystem Prometheus interceptors use in Go and Java, so a dashboard built against one gRPC service recognizes the shape of metrics from any other.</a:t>
+              <a:t>This figure lays out the three observability surfaces this chapter wires up in one process: Prometheus metrics scraped from GET /metrics on a co-located FastAPI app, a grpc.health.v1.Health service any orchestrator can poll, and OTLP traces exported by the zero-code opentelemetry-instrument wrapper. None of these are automatic the way they are on the Quarkus side — grpcio ships no Prometheus binder and no automatic health registration, so both are hand-wired here, in code shown next, following the exact same interceptor pattern Chapter 12 and Chapter 20 already established. The metric and label names — grpc_server_handled_total, grpc_server_handling_seconds, labeled by grpc_service, grpc_method, grpc_code — match the names the community's grpc-ecosystem Prometheus interceptors use in Go and Java, so a dashboard built against one gRPC service recognizes the shape of metrics from any other.</a:t>
             </a:r>
             <a:endParaRPr lang="en-US" dirty="0"/>
           </a:p>
@@ -4001,7 +4001,7 @@
           <a:p>
             <a:r>
               <a:rPr lang="en-US" dirty="0"/>
-              <a:t>This is the minikube-tier demonstration, run by hand on a real generic Kubernetes cluster rather than in CI, because it genuinely needs multiple pods and a cluster DNS to show. A plain ClusterIP Service is a virtual IP with no process behind it; kube-proxy rewrites a connection's destination to one backing pod exactly once, at connection time, not per request. For a gRPC client doing exactly what Chapter 7 recommends — build one channel, reuse it for the process lifetime — that one connection-time decision sticks for every call the channel ever carries. Thirty calls against a three-replica Deployment land on one pod, every time, while the other two sit idle and ready. Nothing here is misconfigured; it's the correct, recommended client behavior colliding with the one Kubernetes primitive most engineers reach for first.</a:t>
+              <a:t>This is the minikube-tier demonstration, run by hand on a real generic Kubernetes cluster rather than in CI, because it needs multiple pods and a cluster DNS to show. A plain ClusterIP Service is a virtual IP with no process behind it; kube-proxy rewrites a connection's destination to one backing pod exactly once, at connection time, not per request. For a gRPC client doing exactly what Chapter 7 recommends — build one channel, reuse it for the process lifetime — that one connection-time decision sticks for every call the channel ever carries. Thirty calls against a three-replica Deployment land on one pod, every time, while the other two sit idle and ready. Nothing here is misconfigured; it's the correct, recommended client behavior colliding with the one Kubernetes primitive most engineers reach for first.</a:t>
             </a:r>
             <a:endParaRPr lang="en-US" dirty="0"/>
           </a:p>
@@ -4705,7 +4705,7 @@
           <a:p>
             <a:r>
               <a:rPr lang="en-US" dirty="0"/>
-              <a:t>Two small, deterministic probes, each proving exactly one thing this chapter's prose claims. trace_probe.py exists so GRPC_TRACE and GRPC_VERBOSITY, set in the container environment around this one GetQuote call, have a call to actually log — grpc-python wraps the same C-core implementation grpc-java and grpc-c++ embed, so these two environment variables surface its internal transport and call activity, while grpcurl, built on grpc-go from scratch, doesn't read either variable at all and needs GRPC_GO_LOG_VERBOSITY_LEVEL instead. unavailable_probe.py proves a subtler point: grpc.aio.insecure_channel returns immediately without dialing anything — a real application channel is lazy — so a call against a target nothing is listening on surfaces as a genuine gRPC status, UNAVAILABLE, on the RPC itself, which is a status grpcurl can never produce for this exact condition, because grpcurl dials blocking, before any RPC, and reports a raw connection-refused error with no status code at all.</a:t>
+              <a:t>Two small, deterministic probes, each proving exactly one thing this chapter's prose claims. trace_probe.py exists so GRPC_TRACE and GRPC_VERBOSITY, set in the container environment around this one GetQuote call, have a call to actually log — grpc-python wraps the same C-core implementation grpc-java and grpc-c++ embed, so these two environment variables surface its internal transport and call activity, while grpcurl, built on grpc-go from scratch, doesn't read either variable at all and needs GRPC_GO_LOG_VERBOSITY_LEVEL instead. unavailable_probe.py proves a subtler point: grpc.aio.insecure_channel returns immediately without dialing anything — a real application channel is lazy — so a call against a target nothing is listening on surfaces as a gRPC status, UNAVAILABLE, on the RPC itself, which is a status grpcurl can never produce for this exact condition, because grpcurl dials blocking, before any RPC, and reports a raw connection-refused error with no status code at all.</a:t>
             </a:r>
             <a:endParaRPr lang="en-US" dirty="0"/>
           </a:p>
@@ -4881,7 +4881,7 @@
           <a:p>
             <a:r>
               <a:rPr lang="en-US" dirty="0"/>
-              <a:t>This architecture figure is the deck's destination: every pattern from every earlier section lands in this one process. mTLS from the TLS section secures the external port; the AuthzInterceptor from the authn/authz section gates every call except reflection and health; a loopback channel — the same one-channel-many-stubs discipline from the unary RPC section — lets RoutingService call QuoteService as a genuine internal gRPC hop, now carrying its own internal service bearer token rather than running in the clear; TrackingService contributes WatchShipment and ReportPositions from the streaming section; and grpc.health.v1.Health, wired by hand exactly as the observability section showed, reports SERVING for all three services plus the overall server. A co-located FastAPI app exposes POST /booking/quote as the one HTTP entry point into this otherwise all-gRPC system, and opentelemetry-instrument ties the gRPC server, the internal gRPC client, and the FastAPI app into one trace per request.</a:t>
+              <a:t>This architecture figure is the deck's destination: every pattern from every earlier section lands in this one process. mTLS from the TLS section secures the external port; the AuthzInterceptor from the authn/authz section gates every call except reflection and health; a loopback channel — the same one-channel-many-stubs discipline from the unary RPC section — lets RoutingService call QuoteService as an internal gRPC hop, now carrying its own internal service bearer token rather than running in the clear; TrackingService contributes WatchShipment and ReportPositions from the streaming section; and grpc.health.v1.Health, wired by hand exactly as the observability section showed, reports SERVING for all three services plus the overall server. A co-located FastAPI app exposes POST /booking/quote as the one HTTP entry point into this otherwise all-gRPC system, and opentelemetry-instrument ties the gRPC server, the internal gRPC client, and the FastAPI app into one trace per request.</a:t>
             </a:r>
             <a:endParaRPr lang="en-US" dirty="0"/>
           </a:p>
@@ -5145,7 +5145,7 @@
           <a:p>
             <a:r>
               <a:rPr lang="en-US" dirty="0"/>
-              <a:t>This is the full dependency surface the Python side of this book leans on, and it's deliberately small. grpc.aio and its generated stub classes are the core; grpcio-tools is build-time only, never shipped at runtime; grpcio-reflection and grpcio-health-checking add the two discovery and liveness surfaces every chapter after the first relies on; grpcio-status bridges the google.rpc rich error model into real gRPC trailers. PyJWT does signature and expiry verification with a hardcoded demo secret — explicitly called out as demo-only, since a production service verifies against an IdP's published JWKS instead. prometheus_client and opentelemetry-distro cover the two observability surfaces; pytest-asyncio is the one testing library the async servicer shape specifically requires, since grpc_testing's fake channel has no asyncio support at all. uv manages every project's dependencies, pinned and declarative, and every image builds on the same UBI 10 Python minimal base. None of this is a managed cloud service — everything here runs unchanged on Docker Engine, on minikube, or on OpenShift Local, which is the same constraint every other deck in this series holds.</a:t>
+              <a:t>This is the full dependency surface the Python side of this book leans on, and it stays small. grpc.aio and its generated stub classes are the core; grpcio-tools is build-time only, never shipped at runtime; grpcio-reflection and grpcio-health-checking add the two discovery and liveness surfaces every chapter after the first relies on; grpcio-status bridges the google.rpc rich error model into real gRPC trailers. PyJWT does signature and expiry verification with a hardcoded demo secret — explicitly called out as demo-only, since a production service verifies against an IdP's published JWKS instead. prometheus_client and opentelemetry-distro cover the two observability surfaces; pytest-asyncio is the one testing library the async servicer shape specifically requires, since grpc_testing's fake channel has no asyncio support at all. uv manages every project's dependencies, pinned and declarative, and every image builds on the same UBI 10 Python minimal base. None of this is a managed cloud service — everything here runs unchanged on Docker Engine, on minikube, or on OpenShift Local, which is the same constraint every other deck in this series holds.</a:t>
             </a:r>
             <a:endParaRPr lang="en-US" dirty="0"/>
           </a:p>
@@ -5233,7 +5233,7 @@
           <a:p>
             <a:r>
               <a:rPr lang="en-US" dirty="0"/>
-              <a:t>If one slide survives from this whole deck, make it this one. grpc.aio's entire contribution is turning every RPC shape — unary, server streaming, client streaming, bidirectional — into syntax Python already has: async def and await for the simple case, async generators and async for for every streaming direction, with no separate reactive library required. The GIL section is the one piece of this deck that's genuinely different from the JVM story: Python's concurrency model is one event loop on one thread, and asyncio.to_thread is the deliberate, correct answer for blocking work, not a hack — a distinction worth internalizing before the free-threaded build changes some of these assumptions. Interceptors are the one mechanism every cross-cutting concern in this deck reused: logging, auth, metrics, all built the same resolve-then-wrap way. And none of it is hypothetical — every code slide in this deck is lifted directly from a runnable example, gated by the same pytest suite and the same buf breaking check that gate the Quarkus sibling, which is exactly what lets a client treat both implementations as genuinely interchangeable. Questions welcome, and the appendix stays open for anything that needs a longer look.</a:t>
+              <a:t>If one slide survives from this whole deck, make it this one. grpc.aio's entire contribution is turning every RPC shape — unary, server streaming, client streaming, bidirectional — into syntax Python already has: async def and await for the simple case, async generators and async for for every streaming direction, with no separate reactive library required. The GIL section is the one piece of this deck that's different from the JVM story: Python's concurrency model is one event loop on one thread, and asyncio.to_thread is the deliberate, correct answer for blocking work, not a hack — a distinction worth internalizing before the free-threaded build changes some of these assumptions. Interceptors are the one mechanism every cross-cutting concern in this deck reused: logging, auth, metrics, all built the same resolve-then-wrap way. And none of it is hypothetical — every code slide in this deck is lifted directly from a runnable example, gated by the same pytest suite and the same buf breaking check that gate the Quarkus sibling, which is exactly what lets a client treat both implementations as interchangeable. Questions welcome, and the appendix stays open for anything that needs a longer look.</a:t>
             </a:r>
             <a:endParaRPr lang="en-US" dirty="0"/>
           </a:p>
@@ -5761,7 +5761,7 @@
           <a:p>
             <a:r>
               <a:rPr lang="en-US" dirty="0"/>
-              <a:t>Four cases, one baseline. valid signs with the real SECRET, sets exp five minutes in the future, and carries the quote:read scope GetQuote requires. expired is identical except exp is five minutes in the PAST — this proves the interceptor actually checks expiry and not just the signature. wrong-scope keeps a valid signature and a valid expiry but swaps the scope claim to one GetQuote doesn't require, demonstrating that authentication and authorization are genuinely separate checks: this token authenticates fine and only fails the later authorization step. bad-sig signs the identical claims with WRONG_SECRET, the token a caller gets by guessing wrong about the shared secret or forging one without ever having seen the real one — a server that only knows SECRET has to reject it. Minting happens at RUNTIME, inside the already-built image, specifically so exp is always computed against the moment verify.sh actually calls GetQuote, never a timestamp baked in at build time that would eventually go stale between a build and a much later test run.</a:t>
+              <a:t>Four cases, one baseline. valid signs with the real SECRET, sets exp five minutes in the future, and carries the quote:read scope GetQuote requires. expired is identical except exp is five minutes in the PAST — this proves the interceptor actually checks expiry and not just the signature. wrong-scope keeps a valid signature and a valid expiry but swaps the scope claim to one GetQuote doesn't require, demonstrating that authentication and authorization are separate checks: this token authenticates fine and only fails the later authorization step. bad-sig signs the identical claims with WRONG_SECRET, the token a caller gets by guessing wrong about the shared secret or forging one without ever having seen the real one — a server that only knows SECRET has to reject it. Minting happens at RUNTIME, inside the already-built image, specifically so exp is always computed against the moment verify.sh actually calls GetQuote, never a timestamp baked in at build time that would eventually go stale between a build and a much later test run.</a:t>
             </a:r>
             <a:endParaRPr lang="en-US" dirty="0"/>
           </a:p>
@@ -6113,7 +6113,7 @@
           <a:p>
             <a:r>
               <a:rPr lang="en-US" dirty="0"/>
-              <a:t>A quick reference for the debugging tools this deck's body section introduced, gathered in one place. Server reflection is the one capability every chapter in this book turns on, specifically so grpcurl never needs a local checked-out copy of the .proto to list services or describe a method's shape — and it works identically whether the port is plaintext, TLS, or mTLS, since reflection is itself an ordinary unary RPC. GRPC_TRACE and GRPC_VERBOSITY surface the C-core's own internal logging; narrowing GRPC_TRACE to one or two tracer names, call_error and api being common starting points, keeps the output usable rather than overwhelming. grpc-channelz, a separate optional service grpcio-channelz adds, exposes a running process's live channel and subchannel state as a queryable gRPC API in its own right — genuinely different from a log line, since it reflects CURRENT state, not a historical event. The UNAVAILABLE-versus-dial-error distinction is worth remembering on its own: a real application's lazily-dialing channel reports a cold target as a gRPC status on the first RPC, while grpcurl's blocking dial reports the identical condition as a transport-level error with no status code at all.</a:t>
+              <a:t>A quick reference for the debugging tools this deck's body section introduced, gathered in one place. Server reflection is the one capability every chapter in this book turns on, specifically so grpcurl never needs a local checked-out copy of the .proto to list services or describe a method's shape — and it works identically whether the port is plaintext, TLS, or mTLS, since reflection is itself an ordinary unary RPC. GRPC_TRACE and GRPC_VERBOSITY surface the C-core's own internal logging; narrowing GRPC_TRACE to one or two tracer names, call_error and api being common starting points, keeps the output usable rather than overwhelming. grpc-channelz, a separate optional service grpcio-channelz adds, exposes a running process's live channel and subchannel state as a queryable gRPC API in its own right — different from a log line, since it reflects CURRENT state, not a historical event. The UNAVAILABLE-versus-dial-error distinction is worth remembering on its own: a real application's lazily-dialing channel reports a cold target as a gRPC status on the first RPC, while grpcurl's blocking dial reports the identical condition as a transport-level error with no status code at all.</a:t>
             </a:r>
             <a:endParaRPr lang="en-US" dirty="0"/>
           </a:p>
@@ -6201,7 +6201,7 @@
           <a:p>
             <a:r>
               <a:rPr lang="en-US" dirty="0"/>
-              <a:t>Worth stating plainly rather than assuming: this book's generic-Kubernetes target, minikube, is what every pattern in THIS deck — including the load-balancing section's pinned-pod-baseline and headless-plus-round-robin-fix cluster demo — actually runs against and is verified on. The book's separate OpenShift Local appendix, which walks through a binary S2I build, Routes, and OpenShift Service Mesh with STRICT mTLS, is a Quarkus-stack example specifically; there is no python/ directory under that example in this repository, so nothing in this deck claims a Python run against OpenShift Local that was actually built and verified. What IS true, and worth saying out loud, is that nothing about the Python stack's contract, servicer code, or TLS/mTLS wiring is OpenShift-specific — the identical UBI 10 base images and the identical grpc.ssl_server_credentials/add_secure_port call this deck's TLS section showed would carry over to any Kubernetes distribution without modification. For the actually-verified OpenShift Local walkthrough, see the Quarkus sibling deck.</a:t>
+              <a:t>This book's generic-Kubernetes target, minikube, is what every pattern in this deck — including the load-balancing section's pinned-pod-baseline and headless-plus-round-robin-fix cluster demo — runs against and is verified on. The book's separate OpenShift Local appendix, which walks through a binary S2I build, Routes, and OpenShift Service Mesh with STRICT mTLS, is a Quarkus-stack example; there is no python/ directory under that example in this repository, so nothing in this deck claims a Python run against OpenShift Local that was built and verified. Nothing about the Python stack's contract, servicer code, or TLS/mTLS wiring is OpenShift-specific — the identical UBI 10 base images and the identical grpc.ssl_server_credentials/add_secure_port call this deck's TLS section showed would carry over to any Kubernetes distribution without modification. For the verified OpenShift Local walkthrough, see the Quarkus sibling deck.</a:t>
             </a:r>
             <a:endParaRPr lang="en-US" dirty="0"/>
           </a:p>
@@ -6377,7 +6377,7 @@
           <a:p>
             <a:r>
               <a:rPr lang="en-US" dirty="0"/>
-              <a:t>The well-known types solve a problem every schema eventually hits: dates, durations, arbitrary-typed fields, and sparse field selections all need a canonical representation that isn't bespoke per service. google.protobuf.Timestamp is the one used most in this book — it's a message with two int64 fields, seconds and nanos, but the generated Python class adds FromDatetime and ToJsonString helper methods that hide that representation entirely. The diagram shows the same mapping this deck's code slide proves: a Python datetime goes in, an RFC 3339 string comes out on the wire as JSON, and the reverse holds for a client. Money, by contrast, is NOT a well-known type — it's this contract's own message, deliberately modeled with a decimal-string amount field rather than a binary float, specifically so currency arithmetic never silently loses precision the way IEEE 754 would.</a:t>
+              <a:t>The well-known types solve a problem every schema eventually hits: dates, durations, arbitrary-typed fields, and sparse field selections all need a canonical representation that isn't bespoke per service. google.protobuf.Timestamp is the one used most in this book — it's a message with two int64 fields, seconds and nanos, but the generated Python class adds FromDatetime and ToJsonString helper methods that hide that representation entirely. The diagram shows the same mapping this deck's code slide proves: a Python datetime goes in, an RFC 3339 string comes out on the wire as JSON, and the reverse holds for a client. Money, by contrast, is NOT a well-known type — it's this contract's own message, modeled with a decimal-string amount field rather than a binary float, so currency arithmetic never silently loses precision the way IEEE 754 would.</a:t>
             </a:r>
             <a:endParaRPr lang="en-US" dirty="0"/>
           </a:p>

</xml_diff>